<commit_message>
Add live prototype links to README, submission guide and deck
</commit_message>
<xml_diff>
--- a/docs/kritical/TakeSure_BugHunters_KriticalHacks2026.pptx
+++ b/docs/kritical/TakeSure_BugHunters_KriticalHacks2026.pptx
@@ -1962,8 +1962,8 @@
         </p:nvSpPr>
         <p:spPr>
           <a:xfrm>
-            <a:off x="365760" y="1143000"/>
-            <a:ext cx="1737360" cy="566928"/>
+            <a:off x="365760" y="1097280"/>
+            <a:ext cx="1737360" cy="512064"/>
           </a:xfrm>
           <a:prstGeom prst="rect">
             <a:avLst/>
@@ -2001,8 +2001,8 @@
         </p:nvSpPr>
         <p:spPr>
           <a:xfrm>
-            <a:off x="2148840" y="1143000"/>
-            <a:ext cx="6675120" cy="566928"/>
+            <a:off x="2148840" y="1097280"/>
+            <a:ext cx="6675120" cy="512064"/>
           </a:xfrm>
           <a:prstGeom prst="rect">
             <a:avLst/>
@@ -2060,8 +2060,8 @@
         </p:nvSpPr>
         <p:spPr>
           <a:xfrm>
-            <a:off x="365760" y="1801368"/>
-            <a:ext cx="1737360" cy="310896"/>
+            <a:off x="365760" y="1682496"/>
+            <a:ext cx="1737360" cy="274320"/>
           </a:xfrm>
           <a:prstGeom prst="rect">
             <a:avLst/>
@@ -2099,8 +2099,8 @@
         </p:nvSpPr>
         <p:spPr>
           <a:xfrm>
-            <a:off x="2148840" y="1801368"/>
-            <a:ext cx="6675120" cy="310896"/>
+            <a:off x="2148840" y="1682496"/>
+            <a:ext cx="6675120" cy="274320"/>
           </a:xfrm>
           <a:prstGeom prst="rect">
             <a:avLst/>
@@ -2141,8 +2141,8 @@
         </p:nvSpPr>
         <p:spPr>
           <a:xfrm>
-            <a:off x="365760" y="2203704"/>
-            <a:ext cx="1737360" cy="713232"/>
+            <a:off x="365760" y="2029968"/>
+            <a:ext cx="1737360" cy="658368"/>
           </a:xfrm>
           <a:prstGeom prst="rect">
             <a:avLst/>
@@ -2180,8 +2180,8 @@
         </p:nvSpPr>
         <p:spPr>
           <a:xfrm>
-            <a:off x="2148840" y="2203704"/>
-            <a:ext cx="6675120" cy="713232"/>
+            <a:off x="2148840" y="2029968"/>
+            <a:ext cx="6675120" cy="658368"/>
           </a:xfrm>
           <a:prstGeom prst="rect">
             <a:avLst/>
@@ -2313,8 +2313,8 @@
         </p:nvSpPr>
         <p:spPr>
           <a:xfrm>
-            <a:off x="365760" y="3008376"/>
-            <a:ext cx="1737360" cy="310896"/>
+            <a:off x="365760" y="2761488"/>
+            <a:ext cx="1737360" cy="274320"/>
           </a:xfrm>
           <a:prstGeom prst="rect">
             <a:avLst/>
@@ -2352,8 +2352,8 @@
         </p:nvSpPr>
         <p:spPr>
           <a:xfrm>
-            <a:off x="2148840" y="3008376"/>
-            <a:ext cx="6675120" cy="310896"/>
+            <a:off x="2148840" y="2761488"/>
+            <a:ext cx="6675120" cy="274320"/>
           </a:xfrm>
           <a:prstGeom prst="rect">
             <a:avLst/>
@@ -2394,8 +2394,8 @@
         </p:nvSpPr>
         <p:spPr>
           <a:xfrm>
-            <a:off x="365760" y="3410712"/>
-            <a:ext cx="1737360" cy="566928"/>
+            <a:off x="365760" y="3108960"/>
+            <a:ext cx="1737360" cy="512064"/>
           </a:xfrm>
           <a:prstGeom prst="rect">
             <a:avLst/>
@@ -2433,8 +2433,8 @@
         </p:nvSpPr>
         <p:spPr>
           <a:xfrm>
-            <a:off x="2148840" y="3410712"/>
-            <a:ext cx="6675120" cy="566928"/>
+            <a:off x="2148840" y="3108960"/>
+            <a:ext cx="6675120" cy="512064"/>
           </a:xfrm>
           <a:prstGeom prst="rect">
             <a:avLst/>
@@ -2492,8 +2492,8 @@
         </p:nvSpPr>
         <p:spPr>
           <a:xfrm>
-            <a:off x="365760" y="4069080"/>
-            <a:ext cx="1737360" cy="310896"/>
+            <a:off x="365760" y="3694176"/>
+            <a:ext cx="1737360" cy="274320"/>
           </a:xfrm>
           <a:prstGeom prst="rect">
             <a:avLst/>
@@ -2531,8 +2531,8 @@
         </p:nvSpPr>
         <p:spPr>
           <a:xfrm>
-            <a:off x="2148840" y="4069080"/>
-            <a:ext cx="6675120" cy="310896"/>
+            <a:off x="2148840" y="3694176"/>
+            <a:ext cx="6675120" cy="274320"/>
           </a:xfrm>
           <a:prstGeom prst="rect">
             <a:avLst/>
@@ -2568,6 +2568,135 @@
       <p:sp>
         <p:nvSpPr>
           <p:cNvPr id="20" name="Text 17"/>
+          <p:cNvSpPr txBox="1"/>
+          <p:nvPr/>
+        </p:nvSpPr>
+        <p:spPr>
+          <a:xfrm>
+            <a:off x="365760" y="4041648"/>
+            <a:ext cx="1737360" cy="274320"/>
+          </a:xfrm>
+          <a:prstGeom prst="rect">
+            <a:avLst/>
+          </a:prstGeom>
+          <a:noFill/>
+          <a:ln/>
+        </p:spPr>
+        <p:txBody>
+          <a:bodyPr wrap="square" lIns="0" tIns="0" rIns="0" bIns="0" rtlCol="0" anchor="t"/>
+          <a:lstStyle/>
+          <a:p>
+            <a:pPr indent="0" marL="0">
+              <a:buNone/>
+            </a:pPr>
+            <a:r>
+              <a:rPr lang="en-US" sz="1300" b="1" dirty="0">
+                <a:solidFill>
+                  <a:srgbClr val="000000"/>
+                </a:solidFill>
+                <a:latin typeface="Arial" pitchFamily="34" charset="0"/>
+                <a:ea typeface="Arial" pitchFamily="34" charset="-122"/>
+                <a:cs typeface="Arial" pitchFamily="34" charset="-120"/>
+              </a:rPr>
+              <a:t>Live link :</a:t>
+            </a:r>
+            <a:endParaRPr lang="en-US" sz="1300" dirty="0"/>
+          </a:p>
+        </p:txBody>
+      </p:sp>
+      <p:sp>
+        <p:nvSpPr>
+          <p:cNvPr id="21" name="Text 18"/>
+          <p:cNvSpPr txBox="1"/>
+          <p:nvPr/>
+        </p:nvSpPr>
+        <p:spPr>
+          <a:xfrm>
+            <a:off x="2148840" y="4041648"/>
+            <a:ext cx="6675120" cy="274320"/>
+          </a:xfrm>
+          <a:prstGeom prst="rect">
+            <a:avLst/>
+          </a:prstGeom>
+          <a:noFill/>
+          <a:ln/>
+        </p:spPr>
+        <p:txBody>
+          <a:bodyPr wrap="square" lIns="0" tIns="0" rIns="0" bIns="0" rtlCol="0" anchor="t"/>
+          <a:lstStyle/>
+          <a:p>
+            <a:pPr indent="0" marL="0">
+              <a:lnSpc>
+                <a:spcPct val="108000"/>
+              </a:lnSpc>
+              <a:buNone/>
+            </a:pPr>
+            <a:r>
+              <a:rPr lang="en-US" sz="1050" b="1" u="sng" dirty="0">
+                <a:solidFill>
+                  <a:srgbClr val="1155CC"/>
+                </a:solidFill>
+                <a:latin typeface="Arial" pitchFamily="34" charset="0"/>
+                <a:ea typeface="Arial" pitchFamily="34" charset="-122"/>
+                <a:cs typeface="Arial" pitchFamily="34" charset="-120"/>
+                <a:hlinkClick r:id="rId2" invalidUrl="" action="" tgtFrame="" tooltip="" history="1" highlightClick="0" endSnd="0">
+                  <a:extLst>
+                    <a:ext uri="{A12FA001-AC4F-418D-AE19-62706E023703}">
+                      <ahyp:hlinkClr xmlns:ahyp="http://schemas.microsoft.com/office/drawing/2018/hyperlinkcolor" val="tx"/>
+                    </a:ext>
+                  </a:extLst>
+                </a:hlinkClick>
+              </a:rPr>
+              <a:t>https://take-sure.vercel.app</a:t>
+            </a:r>
+            <a:pPr indent="0" marL="0">
+              <a:lnSpc>
+                <a:spcPct val="108000"/>
+              </a:lnSpc>
+              <a:buNone/>
+            </a:pPr>
+            <a:r>
+              <a:rPr lang="en-US" sz="1050" dirty="0">
+                <a:solidFill>
+                  <a:srgbClr val="333333"/>
+                </a:solidFill>
+                <a:latin typeface="Arial" pitchFamily="34" charset="0"/>
+                <a:ea typeface="Arial" pitchFamily="34" charset="-122"/>
+                <a:cs typeface="Arial" pitchFamily="34" charset="-120"/>
+              </a:rPr>
+              <a:t>   ·   GitHub: </a:t>
+            </a:r>
+            <a:pPr indent="0" marL="0">
+              <a:lnSpc>
+                <a:spcPct val="108000"/>
+              </a:lnSpc>
+              <a:buNone/>
+            </a:pPr>
+            <a:r>
+              <a:rPr lang="en-US" sz="1050" u="sng" dirty="0">
+                <a:solidFill>
+                  <a:srgbClr val="1155CC"/>
+                </a:solidFill>
+                <a:latin typeface="Arial" pitchFamily="34" charset="0"/>
+                <a:ea typeface="Arial" pitchFamily="34" charset="-122"/>
+                <a:cs typeface="Arial" pitchFamily="34" charset="-120"/>
+                <a:hlinkClick r:id="rId3" invalidUrl="" action="" tgtFrame="" tooltip="" history="1" highlightClick="0" endSnd="0">
+                  <a:extLst>
+                    <a:ext uri="{A12FA001-AC4F-418D-AE19-62706E023703}">
+                      <ahyp:hlinkClr xmlns:ahyp="http://schemas.microsoft.com/office/drawing/2018/hyperlinkcolor" val="tx"/>
+                    </a:ext>
+                  </a:extLst>
+                </a:hlinkClick>
+              </a:rPr>
+              <a:t>github.com/khushi082007-netizen/takesure</a:t>
+            </a:r>
+            <a:endParaRPr lang="en-US" sz="1050" dirty="0"/>
+          </a:p>
+        </p:txBody>
+      </p:sp>
+      <p:sp>
+        <p:nvSpPr>
+          <p:cNvPr id="22" name="Text 19"/>
           <p:cNvSpPr txBox="1"/>
           <p:nvPr/>
         </p:nvSpPr>

</xml_diff>